<commit_message>
React filter 강의 준비 8/5
</commit_message>
<xml_diff>
--- a/material/[SeSAC_YDP_6] 25_React_Event_handling.pptx
+++ b/material/[SeSAC_YDP_6] 25_React_Event_handling.pptx
@@ -17,8 +17,8 @@
     <p:sldId id="261" r:id="rId8"/>
     <p:sldId id="262" r:id="rId9"/>
     <p:sldId id="263" r:id="rId10"/>
-    <p:sldId id="268" r:id="rId11"/>
-    <p:sldId id="269" r:id="rId12"/>
+    <p:sldId id="269" r:id="rId11"/>
+    <p:sldId id="268" r:id="rId12"/>
   </p:sldIdLst>
   <p:sldSz cx="12192000" cy="6858000"/>
   <p:notesSz cx="6858000" cy="9144000"/>
@@ -606,7 +606,7 @@
           <a:lstStyle/>
           <a:p>
             <a:r>
-              <a:rPr lang="en-US" altLang="ko-KR" sz="1200" b="0" kern="1200" dirty="0" smtClean="0">
+              <a:rPr lang="en-US" altLang="ko-KR" sz="1200" b="0" kern="1200" dirty="0">
                 <a:solidFill>
                   <a:schemeClr val="tx1"/>
                 </a:solidFill>
@@ -618,7 +618,7 @@
               <a:t>- HTML : </a:t>
             </a:r>
             <a:r>
-              <a:rPr lang="en-US" altLang="ko-KR" sz="1200" b="0" kern="1200" dirty="0" err="1" smtClean="0">
+              <a:rPr lang="en-US" altLang="ko-KR" sz="1200" b="0" kern="1200" dirty="0" err="1">
                 <a:solidFill>
                   <a:schemeClr val="tx1"/>
                 </a:solidFill>
@@ -630,7 +630,7 @@
               <a:t>onclick</a:t>
             </a:r>
             <a:r>
-              <a:rPr lang="en-US" altLang="ko-KR" sz="1200" b="0" kern="1200" dirty="0" smtClean="0">
+              <a:rPr lang="en-US" altLang="ko-KR" sz="1200" b="0" kern="1200" dirty="0">
                 <a:solidFill>
                   <a:schemeClr val="tx1"/>
                 </a:solidFill>
@@ -642,7 +642,7 @@
               <a:t>="</a:t>
             </a:r>
             <a:r>
-              <a:rPr lang="en-US" altLang="ko-KR" sz="1200" b="0" kern="1200" dirty="0" err="1" smtClean="0">
+              <a:rPr lang="en-US" altLang="ko-KR" sz="1200" b="0" kern="1200" dirty="0" err="1">
                 <a:solidFill>
                   <a:schemeClr val="tx1"/>
                 </a:solidFill>
@@ -654,7 +654,7 @@
               <a:t>onClickEvent</a:t>
             </a:r>
             <a:r>
-              <a:rPr lang="en-US" altLang="ko-KR" sz="1200" b="0" kern="1200" dirty="0" smtClean="0">
+              <a:rPr lang="en-US" altLang="ko-KR" sz="1200" b="0" kern="1200" dirty="0">
                 <a:solidFill>
                   <a:schemeClr val="tx1"/>
                 </a:solidFill>
@@ -666,7 +666,7 @@
               <a:t>()" -&gt; </a:t>
             </a:r>
             <a:r>
-              <a:rPr lang="ko-KR" altLang="en-US" sz="1200" b="0" kern="1200" dirty="0" smtClean="0">
+              <a:rPr lang="ko-KR" altLang="en-US" sz="1200" b="0" kern="1200" dirty="0">
                 <a:solidFill>
                   <a:schemeClr val="tx1"/>
                 </a:solidFill>
@@ -678,7 +678,7 @@
               <a:t>문자열 형식의 </a:t>
             </a:r>
             <a:r>
-              <a:rPr lang="ko-KR" altLang="en-US" sz="1200" b="0" kern="1200" dirty="0" err="1" smtClean="0">
+              <a:rPr lang="ko-KR" altLang="en-US" sz="1200" b="0" kern="1200" dirty="0" err="1">
                 <a:solidFill>
                   <a:schemeClr val="tx1"/>
                 </a:solidFill>
@@ -690,7 +690,7 @@
               <a:t>호출문</a:t>
             </a:r>
             <a:r>
-              <a:rPr lang="ko-KR" altLang="en-US" sz="1200" b="0" kern="1200" dirty="0" smtClean="0">
+              <a:rPr lang="ko-KR" altLang="en-US" sz="1200" b="0" kern="1200" dirty="0">
                 <a:solidFill>
                   <a:schemeClr val="tx1"/>
                 </a:solidFill>
@@ -704,7 +704,7 @@
           </a:p>
           <a:p>
             <a:r>
-              <a:rPr lang="en-US" altLang="ko-KR" sz="1200" b="0" kern="1200" dirty="0" smtClean="0">
+              <a:rPr lang="en-US" altLang="ko-KR" sz="1200" b="0" kern="1200" dirty="0">
                 <a:solidFill>
                   <a:schemeClr val="tx1"/>
                 </a:solidFill>
@@ -716,7 +716,7 @@
               <a:t>- JS : </a:t>
             </a:r>
             <a:r>
-              <a:rPr lang="en-US" altLang="ko-KR" sz="1200" b="0" kern="1200" dirty="0" err="1" smtClean="0">
+              <a:rPr lang="en-US" altLang="ko-KR" sz="1200" b="0" kern="1200" dirty="0" err="1">
                 <a:solidFill>
                   <a:schemeClr val="tx1"/>
                 </a:solidFill>
@@ -728,7 +728,7 @@
               <a:t>addEventListener</a:t>
             </a:r>
             <a:r>
-              <a:rPr lang="en-US" altLang="ko-KR" sz="1200" b="0" kern="1200" dirty="0" smtClean="0">
+              <a:rPr lang="en-US" altLang="ko-KR" sz="1200" b="0" kern="1200" dirty="0">
                 <a:solidFill>
                   <a:schemeClr val="tx1"/>
                 </a:solidFill>
@@ -740,7 +740,7 @@
               <a:t>('click', </a:t>
             </a:r>
             <a:r>
-              <a:rPr lang="en-US" altLang="ko-KR" sz="1200" b="0" kern="1200" dirty="0" err="1" smtClean="0">
+              <a:rPr lang="en-US" altLang="ko-KR" sz="1200" b="0" kern="1200" dirty="0" err="1">
                 <a:solidFill>
                   <a:schemeClr val="tx1"/>
                 </a:solidFill>
@@ -752,7 +752,7 @@
               <a:t>onClickEvent</a:t>
             </a:r>
             <a:r>
-              <a:rPr lang="en-US" altLang="ko-KR" sz="1200" b="0" kern="1200" dirty="0" smtClean="0">
+              <a:rPr lang="en-US" altLang="ko-KR" sz="1200" b="0" kern="1200" dirty="0">
                 <a:solidFill>
                   <a:schemeClr val="tx1"/>
                 </a:solidFill>
@@ -764,7 +764,7 @@
               <a:t>) -&gt; </a:t>
             </a:r>
             <a:r>
-              <a:rPr lang="ko-KR" altLang="en-US" sz="1200" b="0" kern="1200" dirty="0" smtClean="0">
+              <a:rPr lang="ko-KR" altLang="en-US" sz="1200" b="0" kern="1200" dirty="0">
                 <a:solidFill>
                   <a:schemeClr val="tx1"/>
                 </a:solidFill>
@@ -776,7 +776,7 @@
               <a:t>괄호를 없애 함수를 바로 실행하지 않고</a:t>
             </a:r>
             <a:r>
-              <a:rPr lang="en-US" altLang="ko-KR" sz="1200" b="0" kern="1200" dirty="0" smtClean="0">
+              <a:rPr lang="en-US" altLang="ko-KR" sz="1200" b="0" kern="1200" dirty="0">
                 <a:solidFill>
                   <a:schemeClr val="tx1"/>
                 </a:solidFill>
@@ -788,7 +788,7 @@
               <a:t>, </a:t>
             </a:r>
             <a:r>
-              <a:rPr lang="ko-KR" altLang="en-US" sz="1200" b="0" kern="1200" dirty="0" smtClean="0">
+              <a:rPr lang="ko-KR" altLang="en-US" sz="1200" b="0" kern="1200" dirty="0">
                 <a:solidFill>
                   <a:schemeClr val="tx1"/>
                 </a:solidFill>
@@ -800,7 +800,7 @@
               <a:t>클릭 발생 했을 때 함수가 호출되도록 함</a:t>
             </a:r>
             <a:r>
-              <a:rPr lang="en-US" altLang="ko-KR" sz="1200" b="0" kern="1200" dirty="0" smtClean="0">
+              <a:rPr lang="en-US" altLang="ko-KR" sz="1200" b="0" kern="1200" dirty="0">
                 <a:solidFill>
                   <a:schemeClr val="tx1"/>
                 </a:solidFill>
@@ -811,7 +811,7 @@
               </a:rPr>
               <a:t>.</a:t>
             </a:r>
-            <a:endParaRPr lang="ko-KR" altLang="en-US" sz="1200" b="0" kern="1200" dirty="0" smtClean="0">
+            <a:endParaRPr lang="ko-KR" altLang="en-US" sz="1200" b="0" kern="1200" dirty="0">
               <a:solidFill>
                 <a:schemeClr val="tx1"/>
               </a:solidFill>
@@ -823,7 +823,7 @@
           </a:p>
           <a:p>
             <a:r>
-              <a:rPr lang="en-US" altLang="ko-KR" sz="1200" b="0" kern="1200" dirty="0" smtClean="0">
+              <a:rPr lang="en-US" altLang="ko-KR" sz="1200" b="0" kern="1200" dirty="0">
                 <a:solidFill>
                   <a:schemeClr val="tx1"/>
                 </a:solidFill>
@@ -835,7 +835,7 @@
               <a:t>- React : </a:t>
             </a:r>
             <a:r>
-              <a:rPr lang="en-US" altLang="ko-KR" sz="1200" b="0" kern="1200" dirty="0" err="1" smtClean="0">
+              <a:rPr lang="en-US" altLang="ko-KR" sz="1200" b="0" kern="1200" dirty="0" err="1">
                 <a:solidFill>
                   <a:schemeClr val="tx1"/>
                 </a:solidFill>
@@ -847,7 +847,7 @@
               <a:t>onClick</a:t>
             </a:r>
             <a:r>
-              <a:rPr lang="en-US" altLang="ko-KR" sz="1200" b="0" kern="1200" dirty="0" smtClean="0">
+              <a:rPr lang="en-US" altLang="ko-KR" sz="1200" b="0" kern="1200" dirty="0">
                 <a:solidFill>
                   <a:schemeClr val="tx1"/>
                 </a:solidFill>
@@ -859,7 +859,7 @@
               <a:t>={</a:t>
             </a:r>
             <a:r>
-              <a:rPr lang="en-US" altLang="ko-KR" sz="1200" b="0" kern="1200" dirty="0" err="1" smtClean="0">
+              <a:rPr lang="en-US" altLang="ko-KR" sz="1200" b="0" kern="1200" dirty="0" err="1">
                 <a:solidFill>
                   <a:schemeClr val="tx1"/>
                 </a:solidFill>
@@ -871,7 +871,7 @@
               <a:t>onClickEvent</a:t>
             </a:r>
             <a:r>
-              <a:rPr lang="en-US" altLang="ko-KR" sz="1200" b="0" kern="1200" dirty="0" smtClean="0">
+              <a:rPr lang="en-US" altLang="ko-KR" sz="1200" b="0" kern="1200" dirty="0">
                 <a:solidFill>
                   <a:schemeClr val="tx1"/>
                 </a:solidFill>
@@ -883,7 +883,7 @@
               <a:t>} -&gt; JS</a:t>
             </a:r>
             <a:r>
-              <a:rPr lang="ko-KR" altLang="en-US" sz="1200" b="0" kern="1200" dirty="0" smtClean="0">
+              <a:rPr lang="ko-KR" altLang="en-US" sz="1200" b="0" kern="1200" dirty="0">
                 <a:solidFill>
                   <a:schemeClr val="tx1"/>
                 </a:solidFill>
@@ -1065,10 +1065,9 @@
           <a:lstStyle/>
           <a:p>
             <a:r>
-              <a:rPr lang="ko-KR" altLang="en-US" dirty="0" smtClean="0"/>
+              <a:rPr lang="ko-KR" altLang="en-US" dirty="0"/>
               <a:t>링크 들어가서 나오는 코드 보면서 설명해주기</a:t>
             </a:r>
-            <a:endParaRPr lang="ko-KR" altLang="en-US" dirty="0"/>
           </a:p>
         </p:txBody>
       </p:sp>
@@ -1153,73 +1152,69 @@
           <a:lstStyle/>
           <a:p>
             <a:r>
-              <a:rPr lang="en-US" altLang="ko-KR" baseline="0" dirty="0" err="1" smtClean="0"/>
+              <a:rPr lang="en-US" altLang="ko-KR" baseline="0" dirty="0" err="1"/>
               <a:t>js</a:t>
             </a:r>
             <a:r>
-              <a:rPr lang="ko-KR" altLang="en-US" baseline="0" dirty="0" smtClean="0"/>
+              <a:rPr lang="ko-KR" altLang="en-US" baseline="0" dirty="0"/>
               <a:t>에서 클래스 메서드는 기본적으로 </a:t>
             </a:r>
             <a:r>
-              <a:rPr lang="ko-KR" altLang="en-US" baseline="0" dirty="0" err="1" smtClean="0"/>
+              <a:rPr lang="ko-KR" altLang="en-US" baseline="0" dirty="0" err="1"/>
               <a:t>바인딩되어</a:t>
             </a:r>
             <a:r>
-              <a:rPr lang="ko-KR" altLang="en-US" baseline="0" dirty="0" smtClean="0"/>
-              <a:t> 있지 </a:t>
-            </a:r>
-            <a:r>
-              <a:rPr lang="ko-KR" altLang="en-US" baseline="0" dirty="0" smtClean="0"/>
-              <a:t>않음</a:t>
-            </a:r>
-            <a:endParaRPr lang="en-US" altLang="ko-KR" baseline="0" dirty="0" smtClean="0"/>
-          </a:p>
-          <a:p>
-            <a:endParaRPr lang="en-US" altLang="ko-KR" baseline="0" dirty="0" smtClean="0"/>
-          </a:p>
-          <a:p>
-            <a:r>
-              <a:rPr lang="en-US" altLang="ko-KR" baseline="0" dirty="0" smtClean="0"/>
+              <a:rPr lang="ko-KR" altLang="en-US" baseline="0" dirty="0"/>
+              <a:t> 있지 않음</a:t>
+            </a:r>
+            <a:endParaRPr lang="en-US" altLang="ko-KR" baseline="0" dirty="0"/>
+          </a:p>
+          <a:p>
+            <a:endParaRPr lang="en-US" altLang="ko-KR" baseline="0" dirty="0"/>
+          </a:p>
+          <a:p>
+            <a:r>
+              <a:rPr lang="en-US" altLang="ko-KR" baseline="0" dirty="0"/>
               <a:t>**</a:t>
             </a:r>
           </a:p>
           <a:p>
             <a:r>
-              <a:rPr lang="en-US" altLang="ko-KR" baseline="0" dirty="0" smtClean="0"/>
+              <a:rPr lang="en-US" altLang="ko-KR" baseline="0" dirty="0"/>
               <a:t>‘bind’ </a:t>
             </a:r>
             <a:r>
-              <a:rPr lang="ko-KR" altLang="en-US" baseline="0" dirty="0" smtClean="0"/>
+              <a:rPr lang="ko-KR" altLang="en-US" baseline="0" dirty="0"/>
               <a:t>메서드로 </a:t>
             </a:r>
             <a:r>
-              <a:rPr lang="en-US" altLang="ko-KR" baseline="0" dirty="0" smtClean="0"/>
+              <a:rPr lang="en-US" altLang="ko-KR" baseline="0" dirty="0"/>
               <a:t>‘this’ </a:t>
             </a:r>
             <a:r>
-              <a:rPr lang="ko-KR" altLang="en-US" baseline="0" dirty="0" smtClean="0"/>
+              <a:rPr lang="ko-KR" altLang="en-US" baseline="0" dirty="0"/>
               <a:t>바인딩</a:t>
             </a:r>
-            <a:endParaRPr lang="en-US" altLang="ko-KR" baseline="0" dirty="0" smtClean="0"/>
-          </a:p>
-          <a:p>
-            <a:endParaRPr lang="en-US" altLang="ko-KR" dirty="0" smtClean="0"/>
-          </a:p>
-          <a:p>
-            <a:r>
-              <a:rPr lang="en-US" altLang="ko-KR" dirty="0" smtClean="0"/>
+            <a:endParaRPr lang="en-US" altLang="ko-KR" baseline="0" dirty="0"/>
+          </a:p>
+          <a:p>
+            <a:endParaRPr lang="en-US" altLang="ko-KR" dirty="0"/>
+          </a:p>
+          <a:p>
+            <a:r>
+              <a:rPr lang="en-US" altLang="ko-KR" dirty="0"/>
               <a:t>*** </a:t>
             </a:r>
             <a:r>
-              <a:rPr lang="ko-KR" altLang="en-US" dirty="0" smtClean="0"/>
+              <a:rPr lang="ko-KR" altLang="en-US" dirty="0"/>
               <a:t>바인딩이란</a:t>
             </a:r>
             <a:r>
-              <a:rPr lang="en-US" altLang="ko-KR" dirty="0" smtClean="0"/>
+              <a:rPr lang="en-US" altLang="ko-KR" dirty="0"/>
               <a:t>?</a:t>
             </a:r>
             <a:r>
-              <a:rPr lang="en-US" altLang="ko-KR" baseline="0" dirty="0" smtClean="0"/>
+              <a:rPr lang="en-US" altLang="ko-KR" baseline="0" dirty="0"/>
               <a:t> (Binding)</a:t>
             </a:r>
           </a:p>
@@ -1229,19 +1224,19 @@
               <a:buChar char="-"/>
             </a:pPr>
             <a:r>
-              <a:rPr lang="ko-KR" altLang="en-US" baseline="0" dirty="0" smtClean="0"/>
+              <a:rPr lang="ko-KR" altLang="en-US" baseline="0" dirty="0"/>
               <a:t>프로그램의 어떤 기본단위가 가질 수 있는 구성요소의 구체적인 값</a:t>
             </a:r>
             <a:r>
-              <a:rPr lang="en-US" altLang="ko-KR" baseline="0" dirty="0" smtClean="0"/>
+              <a:rPr lang="en-US" altLang="ko-KR" baseline="0" dirty="0"/>
               <a:t>, </a:t>
             </a:r>
             <a:r>
-              <a:rPr lang="ko-KR" altLang="en-US" baseline="0" dirty="0" smtClean="0"/>
+              <a:rPr lang="ko-KR" altLang="en-US" baseline="0" dirty="0"/>
               <a:t>성격을 확정하는 것</a:t>
             </a:r>
             <a:r>
-              <a:rPr lang="en-US" altLang="ko-KR" baseline="0" dirty="0" smtClean="0"/>
+              <a:rPr lang="en-US" altLang="ko-KR" baseline="0" dirty="0"/>
               <a:t>!</a:t>
             </a:r>
           </a:p>
@@ -1251,15 +1246,15 @@
               <a:buChar char="-"/>
             </a:pPr>
             <a:r>
-              <a:rPr lang="en-US" altLang="ko-KR" baseline="0" dirty="0" smtClean="0"/>
+              <a:rPr lang="en-US" altLang="ko-KR" baseline="0" dirty="0"/>
               <a:t>‘this’</a:t>
             </a:r>
             <a:r>
-              <a:rPr lang="ko-KR" altLang="en-US" baseline="0" dirty="0" smtClean="0"/>
+              <a:rPr lang="ko-KR" altLang="en-US" baseline="0" dirty="0"/>
               <a:t>는 함수가 호출되는 방식에 따라 달라짐</a:t>
             </a:r>
             <a:r>
-              <a:rPr lang="en-US" altLang="ko-KR" baseline="0" dirty="0" smtClean="0"/>
+              <a:rPr lang="en-US" altLang="ko-KR" baseline="0" dirty="0"/>
               <a:t>.</a:t>
             </a:r>
           </a:p>
@@ -1269,19 +1264,19 @@
               <a:buChar char="-"/>
             </a:pPr>
             <a:r>
-              <a:rPr lang="ko-KR" altLang="en-US" baseline="0" dirty="0" smtClean="0"/>
+              <a:rPr lang="ko-KR" altLang="en-US" baseline="0" dirty="0"/>
               <a:t>즉</a:t>
             </a:r>
             <a:r>
-              <a:rPr lang="en-US" altLang="ko-KR" baseline="0" dirty="0" smtClean="0"/>
+              <a:rPr lang="en-US" altLang="ko-KR" baseline="0" dirty="0"/>
               <a:t>, ‘this’</a:t>
             </a:r>
             <a:r>
-              <a:rPr lang="ko-KR" altLang="en-US" baseline="0" dirty="0" smtClean="0"/>
+              <a:rPr lang="ko-KR" altLang="en-US" baseline="0" dirty="0"/>
               <a:t>가 무엇을 가리키는지 명확하게 해주기 위해 바인딩이 필요</a:t>
             </a:r>
             <a:r>
-              <a:rPr lang="en-US" altLang="ko-KR" baseline="0" dirty="0" smtClean="0"/>
+              <a:rPr lang="en-US" altLang="ko-KR" baseline="0" dirty="0"/>
               <a:t>.</a:t>
             </a:r>
           </a:p>
@@ -1291,15 +1286,15 @@
               <a:buChar char="-"/>
             </a:pPr>
             <a:r>
-              <a:rPr lang="en-US" altLang="ko-KR" dirty="0" smtClean="0"/>
+              <a:rPr lang="en-US" altLang="ko-KR" dirty="0"/>
               <a:t>this</a:t>
             </a:r>
             <a:r>
-              <a:rPr lang="ko-KR" altLang="en-US" dirty="0" smtClean="0"/>
+              <a:rPr lang="ko-KR" altLang="en-US" dirty="0"/>
               <a:t>가 올바른 객체를 가리키도록 설정하는 작업</a:t>
             </a:r>
             <a:r>
-              <a:rPr lang="en-US" altLang="ko-KR" dirty="0" smtClean="0"/>
+              <a:rPr lang="en-US" altLang="ko-KR" dirty="0"/>
               <a:t>.</a:t>
             </a:r>
           </a:p>
@@ -1308,24 +1303,24 @@
               <a:buFontTx/>
               <a:buChar char="-"/>
             </a:pPr>
-            <a:endParaRPr lang="en-US" altLang="ko-KR" dirty="0" smtClean="0"/>
-          </a:p>
-          <a:p>
-            <a:r>
-              <a:rPr lang="en-US" altLang="ko-KR" dirty="0" smtClean="0"/>
+            <a:endParaRPr lang="en-US" altLang="ko-KR" dirty="0"/>
+          </a:p>
+          <a:p>
+            <a:r>
+              <a:rPr lang="en-US" altLang="ko-KR" dirty="0"/>
               <a:t>**</a:t>
             </a:r>
           </a:p>
           <a:p>
             <a:r>
-              <a:rPr lang="en-US" altLang="ko-KR" dirty="0" smtClean="0"/>
+              <a:rPr lang="en-US" altLang="ko-KR" dirty="0"/>
               <a:t>‘bind’ </a:t>
             </a:r>
             <a:r>
-              <a:rPr lang="ko-KR" altLang="en-US" dirty="0" smtClean="0"/>
+              <a:rPr lang="ko-KR" altLang="en-US" dirty="0"/>
               <a:t>피하기 위한 방법</a:t>
             </a:r>
-            <a:endParaRPr lang="en-US" altLang="ko-KR" dirty="0" smtClean="0"/>
+            <a:endParaRPr lang="en-US" altLang="ko-KR" dirty="0"/>
           </a:p>
           <a:p>
             <a:pPr marL="171450" indent="-171450">
@@ -1333,19 +1328,19 @@
               <a:buChar char="-"/>
             </a:pPr>
             <a:r>
-              <a:rPr lang="ko-KR" altLang="en-US" dirty="0" smtClean="0"/>
+              <a:rPr lang="ko-KR" altLang="en-US" dirty="0"/>
               <a:t>매번 </a:t>
             </a:r>
             <a:r>
-              <a:rPr lang="en-US" altLang="ko-KR" dirty="0" smtClean="0"/>
+              <a:rPr lang="en-US" altLang="ko-KR" dirty="0"/>
               <a:t>‘bind’</a:t>
             </a:r>
             <a:r>
-              <a:rPr lang="ko-KR" altLang="en-US" dirty="0" smtClean="0"/>
+              <a:rPr lang="ko-KR" altLang="en-US" dirty="0"/>
               <a:t>를 사용하는 것이 번거롭다면</a:t>
             </a:r>
             <a:r>
-              <a:rPr lang="en-US" altLang="ko-KR" dirty="0" smtClean="0"/>
+              <a:rPr lang="en-US" altLang="ko-KR" dirty="0"/>
               <a:t>,</a:t>
             </a:r>
           </a:p>
@@ -1355,19 +1350,19 @@
               <a:buNone/>
             </a:pPr>
             <a:r>
-              <a:rPr lang="en-US" altLang="ko-KR" dirty="0" smtClean="0"/>
+              <a:rPr lang="en-US" altLang="ko-KR" dirty="0"/>
               <a:t>#1</a:t>
             </a:r>
             <a:r>
-              <a:rPr lang="en-US" altLang="ko-KR" baseline="0" dirty="0" smtClean="0"/>
+              <a:rPr lang="en-US" altLang="ko-KR" baseline="0" dirty="0"/>
               <a:t> </a:t>
             </a:r>
             <a:r>
-              <a:rPr lang="ko-KR" altLang="en-US" baseline="0" dirty="0" smtClean="0"/>
+              <a:rPr lang="ko-KR" altLang="en-US" baseline="0" dirty="0"/>
               <a:t>화살표 함수 이용</a:t>
             </a:r>
             <a:r>
-              <a:rPr lang="en-US" altLang="ko-KR" baseline="0" dirty="0" smtClean="0"/>
+              <a:rPr lang="en-US" altLang="ko-KR" baseline="0" dirty="0"/>
               <a:t>.</a:t>
             </a:r>
           </a:p>
@@ -1377,39 +1372,39 @@
               <a:buNone/>
             </a:pPr>
             <a:r>
-              <a:rPr lang="en-US" altLang="ko-KR" baseline="0" dirty="0" smtClean="0"/>
+              <a:rPr lang="en-US" altLang="ko-KR" baseline="0" dirty="0"/>
               <a:t>-&gt; </a:t>
             </a:r>
             <a:r>
-              <a:rPr lang="ko-KR" altLang="en-US" baseline="0" dirty="0" smtClean="0"/>
+              <a:rPr lang="ko-KR" altLang="en-US" baseline="0" dirty="0"/>
               <a:t>화살표 함수를 사용하면 </a:t>
             </a:r>
             <a:r>
-              <a:rPr lang="en-US" altLang="ko-KR" baseline="0" dirty="0" smtClean="0"/>
+              <a:rPr lang="en-US" altLang="ko-KR" baseline="0" dirty="0"/>
               <a:t>‘this’</a:t>
             </a:r>
             <a:r>
-              <a:rPr lang="ko-KR" altLang="en-US" baseline="0" dirty="0" smtClean="0"/>
+              <a:rPr lang="ko-KR" altLang="en-US" baseline="0" dirty="0"/>
               <a:t>가 자동으로 바인딩 되므로 </a:t>
             </a:r>
             <a:r>
-              <a:rPr lang="en-US" altLang="ko-KR" baseline="0" dirty="0" smtClean="0"/>
+              <a:rPr lang="en-US" altLang="ko-KR" baseline="0" dirty="0"/>
               <a:t>‘bind’</a:t>
             </a:r>
             <a:r>
-              <a:rPr lang="ko-KR" altLang="en-US" baseline="0" dirty="0" smtClean="0"/>
+              <a:rPr lang="ko-KR" altLang="en-US" baseline="0" dirty="0"/>
               <a:t>를</a:t>
             </a:r>
             <a:r>
-              <a:rPr lang="en-US" altLang="ko-KR" baseline="0" dirty="0" smtClean="0"/>
+              <a:rPr lang="en-US" altLang="ko-KR" baseline="0" dirty="0"/>
               <a:t> </a:t>
             </a:r>
             <a:r>
-              <a:rPr lang="ko-KR" altLang="en-US" baseline="0" dirty="0" smtClean="0"/>
+              <a:rPr lang="ko-KR" altLang="en-US" baseline="0" dirty="0"/>
               <a:t>사용할 필요가 없음</a:t>
             </a:r>
             <a:r>
-              <a:rPr lang="en-US" altLang="ko-KR" baseline="0" dirty="0" smtClean="0"/>
+              <a:rPr lang="en-US" altLang="ko-KR" baseline="0" dirty="0"/>
               <a:t>.</a:t>
             </a:r>
           </a:p>
@@ -1418,7 +1413,7 @@
               <a:buFontTx/>
               <a:buNone/>
             </a:pPr>
-            <a:endParaRPr lang="en-US" altLang="ko-KR" baseline="0" dirty="0" smtClean="0"/>
+            <a:endParaRPr lang="en-US" altLang="ko-KR" baseline="0" dirty="0"/>
           </a:p>
           <a:p>
             <a:pPr marL="0" indent="0">
@@ -1426,18 +1421,18 @@
               <a:buNone/>
             </a:pPr>
             <a:r>
-              <a:rPr lang="en-US" altLang="ko-KR" baseline="0" dirty="0" smtClean="0"/>
+              <a:rPr lang="en-US" altLang="ko-KR" baseline="0" dirty="0"/>
               <a:t>#2 </a:t>
             </a:r>
             <a:r>
-              <a:rPr lang="ko-KR" altLang="en-US" baseline="0" dirty="0" err="1" smtClean="0"/>
+              <a:rPr lang="ko-KR" altLang="en-US" baseline="0" dirty="0" err="1"/>
               <a:t>생성자에게</a:t>
             </a:r>
             <a:r>
-              <a:rPr lang="ko-KR" altLang="en-US" baseline="0" dirty="0" smtClean="0"/>
+              <a:rPr lang="ko-KR" altLang="en-US" baseline="0" dirty="0"/>
               <a:t> 바인딩하기</a:t>
             </a:r>
-            <a:endParaRPr lang="en-US" altLang="ko-KR" baseline="0" dirty="0" smtClean="0"/>
+            <a:endParaRPr lang="en-US" altLang="ko-KR" baseline="0" dirty="0"/>
           </a:p>
           <a:p>
             <a:pPr marL="0" indent="0">
@@ -1445,51 +1440,51 @@
               <a:buNone/>
             </a:pPr>
             <a:r>
-              <a:rPr lang="en-US" altLang="ko-KR" dirty="0" smtClean="0"/>
+              <a:rPr lang="en-US" altLang="ko-KR" dirty="0"/>
               <a:t>-&gt; </a:t>
             </a:r>
             <a:r>
-              <a:rPr lang="ko-KR" altLang="en-US" dirty="0" err="1" smtClean="0"/>
+              <a:rPr lang="ko-KR" altLang="en-US" dirty="0" err="1"/>
               <a:t>생성자에서</a:t>
             </a:r>
             <a:r>
-              <a:rPr lang="ko-KR" altLang="en-US" dirty="0" smtClean="0"/>
+              <a:rPr lang="ko-KR" altLang="en-US" dirty="0"/>
               <a:t> 한 번만 </a:t>
             </a:r>
             <a:r>
-              <a:rPr lang="en-US" altLang="ko-KR" dirty="0" smtClean="0"/>
+              <a:rPr lang="en-US" altLang="ko-KR" dirty="0"/>
               <a:t>bind</a:t>
             </a:r>
             <a:r>
-              <a:rPr lang="ko-KR" altLang="en-US" dirty="0" smtClean="0"/>
+              <a:rPr lang="ko-KR" altLang="en-US" dirty="0"/>
               <a:t>를 해두면</a:t>
             </a:r>
             <a:r>
-              <a:rPr lang="en-US" altLang="ko-KR" dirty="0" smtClean="0"/>
+              <a:rPr lang="en-US" altLang="ko-KR" dirty="0"/>
               <a:t>, </a:t>
             </a:r>
             <a:r>
-              <a:rPr lang="ko-KR" altLang="en-US" dirty="0" smtClean="0"/>
+              <a:rPr lang="ko-KR" altLang="en-US" dirty="0"/>
               <a:t>나중에 </a:t>
             </a:r>
             <a:r>
-              <a:rPr lang="en-US" altLang="ko-KR" dirty="0" smtClean="0"/>
+              <a:rPr lang="en-US" altLang="ko-KR" dirty="0"/>
               <a:t>render </a:t>
             </a:r>
             <a:r>
-              <a:rPr lang="ko-KR" altLang="en-US" dirty="0" smtClean="0"/>
+              <a:rPr lang="ko-KR" altLang="en-US" dirty="0"/>
               <a:t>메서드에서 반복적으로 </a:t>
             </a:r>
             <a:r>
-              <a:rPr lang="en-US" altLang="ko-KR" dirty="0" smtClean="0"/>
+              <a:rPr lang="en-US" altLang="ko-KR" dirty="0"/>
               <a:t>bind</a:t>
             </a:r>
             <a:r>
-              <a:rPr lang="ko-KR" altLang="en-US" dirty="0" smtClean="0"/>
+              <a:rPr lang="ko-KR" altLang="en-US" dirty="0"/>
               <a:t>할 필요가 없습니다</a:t>
             </a:r>
             <a:r>
-              <a:rPr lang="en-US" altLang="ko-KR" dirty="0" smtClean="0"/>
+              <a:rPr lang="en-US" altLang="ko-KR" dirty="0"/>
               <a:t>.</a:t>
             </a:r>
             <a:endParaRPr lang="ko-KR" altLang="en-US" dirty="0"/>
@@ -1744,11 +1739,7 @@
           <a:bodyPr/>
           <a:lstStyle/>
           <a:p>
-            <a:r>
-              <a:rPr lang="en-US" altLang="ko-KR" dirty="0"/>
-              <a:t>04_eventhandling</a:t>
-            </a:r>
-            <a:endParaRPr lang="ko-KR" altLang="en-US" dirty="0"/>
+            <a:endParaRPr lang="en-US" altLang="ko-KR" dirty="0"/>
           </a:p>
         </p:txBody>
       </p:sp>
@@ -1778,7 +1769,7 @@
     </p:spTree>
     <p:extLst>
       <p:ext uri="{BB962C8B-B14F-4D97-AF65-F5344CB8AC3E}">
-        <p14:creationId xmlns:p14="http://schemas.microsoft.com/office/powerpoint/2010/main" val="771570096"/>
+        <p14:creationId xmlns:p14="http://schemas.microsoft.com/office/powerpoint/2010/main" val="1832612303"/>
       </p:ext>
     </p:extLst>
   </p:cSld>
@@ -1832,7 +1823,11 @@
           <a:bodyPr/>
           <a:lstStyle/>
           <a:p>
-            <a:endParaRPr lang="en-US" altLang="ko-KR" dirty="0"/>
+            <a:r>
+              <a:rPr lang="en-US" altLang="ko-KR" dirty="0"/>
+              <a:t>04_eventhandling</a:t>
+            </a:r>
+            <a:endParaRPr lang="ko-KR" altLang="en-US" dirty="0"/>
           </a:p>
         </p:txBody>
       </p:sp>
@@ -1862,7 +1857,7 @@
     </p:spTree>
     <p:extLst>
       <p:ext uri="{BB962C8B-B14F-4D97-AF65-F5344CB8AC3E}">
-        <p14:creationId xmlns:p14="http://schemas.microsoft.com/office/powerpoint/2010/main" val="1832612303"/>
+        <p14:creationId xmlns:p14="http://schemas.microsoft.com/office/powerpoint/2010/main" val="771570096"/>
       </p:ext>
     </p:extLst>
   </p:cSld>
@@ -5655,264 +5650,6 @@
       </p:grpSpPr>
       <p:sp>
         <p:nvSpPr>
-          <p:cNvPr id="4" name="날짜 개체 틀 3">
-            <a:extLst>
-              <a:ext uri="{FF2B5EF4-FFF2-40B4-BE49-F238E27FC236}">
-                <a16:creationId xmlns:a16="http://schemas.microsoft.com/office/drawing/2014/main" id="{6EE9B434-8977-A422-69B8-4F63EBA503FB}"/>
-              </a:ext>
-            </a:extLst>
-          </p:cNvPr>
-          <p:cNvSpPr>
-            <a:spLocks noGrp="1"/>
-          </p:cNvSpPr>
-          <p:nvPr>
-            <p:ph type="dt" sz="half" idx="10"/>
-          </p:nvPr>
-        </p:nvSpPr>
-        <p:spPr/>
-        <p:txBody>
-          <a:bodyPr/>
-          <a:lstStyle/>
-          <a:p>
-            <a:fld id="{F5DECA0C-8384-4A80-8CAF-F40503FCCF4C}" type="datetime6">
-              <a:rPr lang="ko-KR" altLang="en-US" smtClean="0"/>
-              <a:t>2024년 8월</a:t>
-            </a:fld>
-            <a:endParaRPr lang="ko-KR" altLang="en-US"/>
-          </a:p>
-        </p:txBody>
-      </p:sp>
-      <p:sp>
-        <p:nvSpPr>
-          <p:cNvPr id="5" name="슬라이드 번호 개체 틀 4">
-            <a:extLst>
-              <a:ext uri="{FF2B5EF4-FFF2-40B4-BE49-F238E27FC236}">
-                <a16:creationId xmlns:a16="http://schemas.microsoft.com/office/drawing/2014/main" id="{75E3E9B0-C628-12AF-B688-62BAA3A8B414}"/>
-              </a:ext>
-            </a:extLst>
-          </p:cNvPr>
-          <p:cNvSpPr>
-            <a:spLocks noGrp="1"/>
-          </p:cNvSpPr>
-          <p:nvPr>
-            <p:ph type="sldNum" sz="quarter" idx="12"/>
-          </p:nvPr>
-        </p:nvSpPr>
-        <p:spPr/>
-        <p:txBody>
-          <a:bodyPr/>
-          <a:lstStyle/>
-          <a:p>
-            <a:fld id="{083A2CE0-18CD-4102-B738-4ACFF9E68BA4}" type="slidenum">
-              <a:rPr lang="ko-KR" altLang="en-US" smtClean="0"/>
-              <a:t>10</a:t>
-            </a:fld>
-            <a:endParaRPr lang="ko-KR" altLang="en-US"/>
-          </a:p>
-        </p:txBody>
-      </p:sp>
-      <p:sp>
-        <p:nvSpPr>
-          <p:cNvPr id="2" name="제목 1">
-            <a:extLst>
-              <a:ext uri="{FF2B5EF4-FFF2-40B4-BE49-F238E27FC236}">
-                <a16:creationId xmlns:a16="http://schemas.microsoft.com/office/drawing/2014/main" id="{6C705268-880D-AF4E-8A90-8B152EB81097}"/>
-              </a:ext>
-            </a:extLst>
-          </p:cNvPr>
-          <p:cNvSpPr>
-            <a:spLocks noGrp="1"/>
-          </p:cNvSpPr>
-          <p:nvPr>
-            <p:ph type="title"/>
-          </p:nvPr>
-        </p:nvSpPr>
-        <p:spPr/>
-        <p:txBody>
-          <a:bodyPr/>
-          <a:lstStyle/>
-          <a:p>
-            <a:r>
-              <a:rPr lang="ko-KR" altLang="en-US" dirty="0">
-                <a:solidFill>
-                  <a:schemeClr val="accent1"/>
-                </a:solidFill>
-              </a:rPr>
-              <a:t>실습</a:t>
-            </a:r>
-            <a:r>
-              <a:rPr lang="en-US" altLang="ko-KR" dirty="0">
-                <a:solidFill>
-                  <a:schemeClr val="accent1"/>
-                </a:solidFill>
-              </a:rPr>
-              <a:t>.</a:t>
-            </a:r>
-            <a:r>
-              <a:rPr lang="ko-KR" altLang="en-US" dirty="0">
-                <a:solidFill>
-                  <a:schemeClr val="accent1"/>
-                </a:solidFill>
-              </a:rPr>
-              <a:t> </a:t>
-            </a:r>
-            <a:r>
-              <a:rPr lang="ko-KR" altLang="en-US" dirty="0" smtClean="0"/>
-              <a:t>종합 실습 </a:t>
-            </a:r>
-            <a:r>
-              <a:rPr lang="en-US" altLang="ko-KR" dirty="0" smtClean="0"/>
-              <a:t>(props, state, event)</a:t>
-            </a:r>
-            <a:endParaRPr lang="ko-KR" altLang="en-US" dirty="0"/>
-          </a:p>
-        </p:txBody>
-      </p:sp>
-      <p:pic>
-        <p:nvPicPr>
-          <p:cNvPr id="3" name="20230927-0126-48.7395426">
-            <a:hlinkClick r:id="" action="ppaction://media"/>
-          </p:cNvPr>
-          <p:cNvPicPr>
-            <a:picLocks noChangeAspect="1"/>
-          </p:cNvPicPr>
-          <p:nvPr>
-            <a:videoFile r:link="rId2"/>
-            <p:extLst>
-              <p:ext uri="{DAA4B4D4-6D71-4841-9C94-3DE7FCFB9230}">
-                <p14:media xmlns:p14="http://schemas.microsoft.com/office/powerpoint/2010/main" r:embed="rId1"/>
-              </p:ext>
-            </p:extLst>
-          </p:nvPr>
-        </p:nvPicPr>
-        <p:blipFill>
-          <a:blip r:embed="rId5"/>
-          <a:stretch>
-            <a:fillRect/>
-          </a:stretch>
-        </p:blipFill>
-        <p:spPr>
-          <a:xfrm>
-            <a:off x="3514543" y="1816372"/>
-            <a:ext cx="4871811" cy="3264361"/>
-          </a:xfrm>
-          <a:prstGeom prst="rect">
-            <a:avLst/>
-          </a:prstGeom>
-        </p:spPr>
-      </p:pic>
-    </p:spTree>
-    <p:extLst>
-      <p:ext uri="{BB962C8B-B14F-4D97-AF65-F5344CB8AC3E}">
-        <p14:creationId xmlns:p14="http://schemas.microsoft.com/office/powerpoint/2010/main" val="3120877233"/>
-      </p:ext>
-    </p:extLst>
-  </p:cSld>
-  <p:clrMapOvr>
-    <a:masterClrMapping/>
-  </p:clrMapOvr>
-  <p:timing>
-    <p:tnLst>
-      <p:par>
-        <p:cTn id="1" dur="indefinite" restart="never" nodeType="tmRoot">
-          <p:childTnLst>
-            <p:seq concurrent="1" nextAc="seek">
-              <p:cTn id="2" restart="whenNotActive" fill="hold" evtFilter="cancelBubble" nodeType="interactiveSeq">
-                <p:stCondLst>
-                  <p:cond evt="onClick" delay="0">
-                    <p:tgtEl>
-                      <p:spTgt spid="3"/>
-                    </p:tgtEl>
-                  </p:cond>
-                </p:stCondLst>
-                <p:endSync evt="end" delay="0">
-                  <p:rtn val="all"/>
-                </p:endSync>
-                <p:childTnLst>
-                  <p:par>
-                    <p:cTn id="3" fill="hold">
-                      <p:stCondLst>
-                        <p:cond delay="0"/>
-                      </p:stCondLst>
-                      <p:childTnLst>
-                        <p:par>
-                          <p:cTn id="4" fill="hold">
-                            <p:stCondLst>
-                              <p:cond delay="0"/>
-                            </p:stCondLst>
-                            <p:childTnLst>
-                              <p:par>
-                                <p:cTn id="5" presetID="2" presetClass="mediacall" presetSubtype="0" fill="hold" nodeType="clickEffect">
-                                  <p:stCondLst>
-                                    <p:cond delay="0"/>
-                                  </p:stCondLst>
-                                  <p:childTnLst>
-                                    <p:cmd type="call" cmd="togglePause">
-                                      <p:cBhvr>
-                                        <p:cTn id="6" dur="1" fill="hold"/>
-                                        <p:tgtEl>
-                                          <p:spTgt spid="3"/>
-                                        </p:tgtEl>
-                                      </p:cBhvr>
-                                    </p:cmd>
-                                  </p:childTnLst>
-                                </p:cTn>
-                              </p:par>
-                            </p:childTnLst>
-                          </p:cTn>
-                        </p:par>
-                      </p:childTnLst>
-                    </p:cTn>
-                  </p:par>
-                </p:childTnLst>
-              </p:cTn>
-              <p:nextCondLst>
-                <p:cond evt="onClick" delay="0">
-                  <p:tgtEl>
-                    <p:spTgt spid="3"/>
-                  </p:tgtEl>
-                </p:cond>
-              </p:nextCondLst>
-            </p:seq>
-            <p:video>
-              <p:cMediaNode vol="80000">
-                <p:cTn id="7" fill="hold" display="0">
-                  <p:stCondLst>
-                    <p:cond delay="indefinite"/>
-                  </p:stCondLst>
-                </p:cTn>
-                <p:tgtEl>
-                  <p:spTgt spid="3"/>
-                </p:tgtEl>
-              </p:cMediaNode>
-            </p:video>
-          </p:childTnLst>
-        </p:cTn>
-      </p:par>
-    </p:tnLst>
-  </p:timing>
-</p:sld>
-</file>
-
-<file path=ppt/slides/slide11.xml><?xml version="1.0" encoding="utf-8"?>
-<p:sld xmlns:a="http://schemas.openxmlformats.org/drawingml/2006/main" xmlns:r="http://schemas.openxmlformats.org/officeDocument/2006/relationships" xmlns:p="http://schemas.openxmlformats.org/presentationml/2006/main">
-  <p:cSld>
-    <p:spTree>
-      <p:nvGrpSpPr>
-        <p:cNvPr id="1" name=""/>
-        <p:cNvGrpSpPr/>
-        <p:nvPr/>
-      </p:nvGrpSpPr>
-      <p:grpSpPr>
-        <a:xfrm>
-          <a:off x="0" y="0"/>
-          <a:ext cx="0" cy="0"/>
-          <a:chOff x="0" y="0"/>
-          <a:chExt cx="0" cy="0"/>
-        </a:xfrm>
-      </p:grpSpPr>
-      <p:sp>
-        <p:nvSpPr>
           <p:cNvPr id="13" name="내용 개체 틀 2">
             <a:extLst>
               <a:ext uri="{FF2B5EF4-FFF2-40B4-BE49-F238E27FC236}">
@@ -6004,7 +5741,7 @@
           <a:p>
             <a:fld id="{083A2CE0-18CD-4102-B738-4ACFF9E68BA4}" type="slidenum">
               <a:rPr lang="ko-KR" altLang="en-US" smtClean="0"/>
-              <a:t>11</a:t>
+              <a:t>10</a:t>
             </a:fld>
             <a:endParaRPr lang="ko-KR" altLang="en-US"/>
           </a:p>
@@ -6052,11 +5789,11 @@
               <a:t> </a:t>
             </a:r>
             <a:r>
-              <a:rPr lang="ko-KR" altLang="en-US" dirty="0" smtClean="0"/>
+              <a:rPr lang="ko-KR" altLang="en-US" dirty="0"/>
               <a:t>이벤트 핸들링</a:t>
             </a:r>
             <a:r>
-              <a:rPr lang="en-US" altLang="ko-KR" dirty="0" smtClean="0"/>
+              <a:rPr lang="en-US" altLang="ko-KR" dirty="0"/>
               <a:t> </a:t>
             </a:r>
             <a:r>
@@ -6327,15 +6064,6 @@
               </a:rPr>
               <a:t>강의 클릭</a:t>
             </a:r>
-            <a:r>
-              <a:rPr lang="en-US" altLang="ko-KR" dirty="0">
-                <a:solidFill>
-                  <a:srgbClr val="212529"/>
-                </a:solidFill>
-                <a:latin typeface="+mn-ea"/>
-              </a:rPr>
-              <a:t/>
-            </a:r>
             <a:br>
               <a:rPr lang="en-US" altLang="ko-KR" dirty="0">
                 <a:solidFill>
@@ -6363,7 +6091,7 @@
               <a:t>➡ </a:t>
             </a:r>
             <a:r>
-              <a:rPr lang="en-US" altLang="ko-KR" sz="2800" b="1" dirty="0" smtClean="0">
+              <a:rPr lang="en-US" altLang="ko-KR" sz="2800" b="1" dirty="0">
                 <a:solidFill>
                   <a:srgbClr val="212529"/>
                 </a:solidFill>
@@ -6372,22 +6100,13 @@
               <a:t>[</a:t>
             </a:r>
             <a:r>
-              <a:rPr lang="ko-KR" altLang="en-US" sz="2800" b="1" dirty="0" smtClean="0">
-                <a:solidFill>
-                  <a:srgbClr val="212529"/>
-                </a:solidFill>
-                <a:latin typeface="+mn-ea"/>
-              </a:rPr>
-              <a:t>이벤트 핸들링 </a:t>
-            </a:r>
-            <a:r>
               <a:rPr lang="ko-KR" altLang="en-US" sz="2800" b="1" dirty="0">
                 <a:solidFill>
                   <a:srgbClr val="212529"/>
                 </a:solidFill>
                 <a:latin typeface="+mn-ea"/>
               </a:rPr>
-              <a:t>실습</a:t>
+              <a:t>이벤트 핸들링 실습</a:t>
             </a:r>
             <a:r>
               <a:rPr lang="en-US" altLang="ko-KR" sz="2800" b="1" dirty="0">
@@ -6441,25 +6160,7 @@
                 </a:solidFill>
                 <a:latin typeface="+mn-ea"/>
               </a:rPr>
-              <a:t>[</a:t>
-            </a:r>
-            <a:r>
-              <a:rPr lang="en-US" altLang="ko-KR" sz="2800" b="1" dirty="0" smtClean="0">
-                <a:solidFill>
-                  <a:schemeClr val="accent1"/>
-                </a:solidFill>
-                <a:latin typeface="+mn-ea"/>
-              </a:rPr>
-              <a:t>1~3</a:t>
-            </a:r>
-            <a:r>
-              <a:rPr lang="ko-KR" altLang="en-US" sz="2800" b="1" dirty="0" smtClean="0">
-                <a:solidFill>
-                  <a:schemeClr val="accent1"/>
-                </a:solidFill>
-                <a:latin typeface="+mn-ea"/>
-              </a:rPr>
-              <a:t>번 </a:t>
+              <a:t>[1~3</a:t>
             </a:r>
             <a:r>
               <a:rPr lang="ko-KR" altLang="en-US" sz="2800" b="1" dirty="0">
@@ -6468,7 +6169,7 @@
                 </a:solidFill>
                 <a:latin typeface="+mn-ea"/>
               </a:rPr>
-              <a:t>문제</a:t>
+              <a:t>번 문제</a:t>
             </a:r>
             <a:r>
               <a:rPr lang="en-US" altLang="ko-KR" sz="2800" b="1" dirty="0">
@@ -6510,6 +6211,264 @@
   <p:clrMapOvr>
     <a:masterClrMapping/>
   </p:clrMapOvr>
+</p:sld>
+</file>
+
+<file path=ppt/slides/slide11.xml><?xml version="1.0" encoding="utf-8"?>
+<p:sld xmlns:a="http://schemas.openxmlformats.org/drawingml/2006/main" xmlns:r="http://schemas.openxmlformats.org/officeDocument/2006/relationships" xmlns:p="http://schemas.openxmlformats.org/presentationml/2006/main">
+  <p:cSld>
+    <p:spTree>
+      <p:nvGrpSpPr>
+        <p:cNvPr id="1" name=""/>
+        <p:cNvGrpSpPr/>
+        <p:nvPr/>
+      </p:nvGrpSpPr>
+      <p:grpSpPr>
+        <a:xfrm>
+          <a:off x="0" y="0"/>
+          <a:ext cx="0" cy="0"/>
+          <a:chOff x="0" y="0"/>
+          <a:chExt cx="0" cy="0"/>
+        </a:xfrm>
+      </p:grpSpPr>
+      <p:sp>
+        <p:nvSpPr>
+          <p:cNvPr id="4" name="날짜 개체 틀 3">
+            <a:extLst>
+              <a:ext uri="{FF2B5EF4-FFF2-40B4-BE49-F238E27FC236}">
+                <a16:creationId xmlns:a16="http://schemas.microsoft.com/office/drawing/2014/main" id="{6EE9B434-8977-A422-69B8-4F63EBA503FB}"/>
+              </a:ext>
+            </a:extLst>
+          </p:cNvPr>
+          <p:cNvSpPr>
+            <a:spLocks noGrp="1"/>
+          </p:cNvSpPr>
+          <p:nvPr>
+            <p:ph type="dt" sz="half" idx="10"/>
+          </p:nvPr>
+        </p:nvSpPr>
+        <p:spPr/>
+        <p:txBody>
+          <a:bodyPr/>
+          <a:lstStyle/>
+          <a:p>
+            <a:fld id="{F5DECA0C-8384-4A80-8CAF-F40503FCCF4C}" type="datetime6">
+              <a:rPr lang="ko-KR" altLang="en-US" smtClean="0"/>
+              <a:t>2024년 8월</a:t>
+            </a:fld>
+            <a:endParaRPr lang="ko-KR" altLang="en-US"/>
+          </a:p>
+        </p:txBody>
+      </p:sp>
+      <p:sp>
+        <p:nvSpPr>
+          <p:cNvPr id="5" name="슬라이드 번호 개체 틀 4">
+            <a:extLst>
+              <a:ext uri="{FF2B5EF4-FFF2-40B4-BE49-F238E27FC236}">
+                <a16:creationId xmlns:a16="http://schemas.microsoft.com/office/drawing/2014/main" id="{75E3E9B0-C628-12AF-B688-62BAA3A8B414}"/>
+              </a:ext>
+            </a:extLst>
+          </p:cNvPr>
+          <p:cNvSpPr>
+            <a:spLocks noGrp="1"/>
+          </p:cNvSpPr>
+          <p:nvPr>
+            <p:ph type="sldNum" sz="quarter" idx="12"/>
+          </p:nvPr>
+        </p:nvSpPr>
+        <p:spPr/>
+        <p:txBody>
+          <a:bodyPr/>
+          <a:lstStyle/>
+          <a:p>
+            <a:fld id="{083A2CE0-18CD-4102-B738-4ACFF9E68BA4}" type="slidenum">
+              <a:rPr lang="ko-KR" altLang="en-US" smtClean="0"/>
+              <a:t>11</a:t>
+            </a:fld>
+            <a:endParaRPr lang="ko-KR" altLang="en-US"/>
+          </a:p>
+        </p:txBody>
+      </p:sp>
+      <p:sp>
+        <p:nvSpPr>
+          <p:cNvPr id="2" name="제목 1">
+            <a:extLst>
+              <a:ext uri="{FF2B5EF4-FFF2-40B4-BE49-F238E27FC236}">
+                <a16:creationId xmlns:a16="http://schemas.microsoft.com/office/drawing/2014/main" id="{6C705268-880D-AF4E-8A90-8B152EB81097}"/>
+              </a:ext>
+            </a:extLst>
+          </p:cNvPr>
+          <p:cNvSpPr>
+            <a:spLocks noGrp="1"/>
+          </p:cNvSpPr>
+          <p:nvPr>
+            <p:ph type="title"/>
+          </p:nvPr>
+        </p:nvSpPr>
+        <p:spPr/>
+        <p:txBody>
+          <a:bodyPr/>
+          <a:lstStyle/>
+          <a:p>
+            <a:r>
+              <a:rPr lang="ko-KR" altLang="en-US" dirty="0">
+                <a:solidFill>
+                  <a:schemeClr val="accent1"/>
+                </a:solidFill>
+              </a:rPr>
+              <a:t>실습</a:t>
+            </a:r>
+            <a:r>
+              <a:rPr lang="en-US" altLang="ko-KR" dirty="0">
+                <a:solidFill>
+                  <a:schemeClr val="accent1"/>
+                </a:solidFill>
+              </a:rPr>
+              <a:t>.</a:t>
+            </a:r>
+            <a:r>
+              <a:rPr lang="ko-KR" altLang="en-US" dirty="0">
+                <a:solidFill>
+                  <a:schemeClr val="accent1"/>
+                </a:solidFill>
+              </a:rPr>
+              <a:t> </a:t>
+            </a:r>
+            <a:r>
+              <a:rPr lang="ko-KR" altLang="en-US" dirty="0"/>
+              <a:t>종합 실습 </a:t>
+            </a:r>
+            <a:r>
+              <a:rPr lang="en-US" altLang="ko-KR" dirty="0"/>
+              <a:t>(props, state, event)</a:t>
+            </a:r>
+            <a:endParaRPr lang="ko-KR" altLang="en-US" dirty="0"/>
+          </a:p>
+        </p:txBody>
+      </p:sp>
+      <p:pic>
+        <p:nvPicPr>
+          <p:cNvPr id="3" name="20230927-0126-48.7395426">
+            <a:hlinkClick r:id="" action="ppaction://media"/>
+          </p:cNvPr>
+          <p:cNvPicPr>
+            <a:picLocks noChangeAspect="1"/>
+          </p:cNvPicPr>
+          <p:nvPr>
+            <a:videoFile r:link="rId2"/>
+            <p:extLst>
+              <p:ext uri="{DAA4B4D4-6D71-4841-9C94-3DE7FCFB9230}">
+                <p14:media xmlns:p14="http://schemas.microsoft.com/office/powerpoint/2010/main" r:embed="rId1"/>
+              </p:ext>
+            </p:extLst>
+          </p:nvPr>
+        </p:nvPicPr>
+        <p:blipFill>
+          <a:blip r:embed="rId5"/>
+          <a:stretch>
+            <a:fillRect/>
+          </a:stretch>
+        </p:blipFill>
+        <p:spPr>
+          <a:xfrm>
+            <a:off x="3514543" y="1816372"/>
+            <a:ext cx="4871811" cy="3264361"/>
+          </a:xfrm>
+          <a:prstGeom prst="rect">
+            <a:avLst/>
+          </a:prstGeom>
+        </p:spPr>
+      </p:pic>
+    </p:spTree>
+    <p:extLst>
+      <p:ext uri="{BB962C8B-B14F-4D97-AF65-F5344CB8AC3E}">
+        <p14:creationId xmlns:p14="http://schemas.microsoft.com/office/powerpoint/2010/main" val="3120877233"/>
+      </p:ext>
+    </p:extLst>
+  </p:cSld>
+  <p:clrMapOvr>
+    <a:masterClrMapping/>
+  </p:clrMapOvr>
+  <p:timing>
+    <p:tnLst>
+      <p:par>
+        <p:cTn id="1" dur="indefinite" restart="never" nodeType="tmRoot">
+          <p:childTnLst>
+            <p:seq concurrent="1" nextAc="seek">
+              <p:cTn id="2" restart="whenNotActive" fill="hold" evtFilter="cancelBubble" nodeType="interactiveSeq">
+                <p:stCondLst>
+                  <p:cond evt="onClick" delay="0">
+                    <p:tgtEl>
+                      <p:spTgt spid="3"/>
+                    </p:tgtEl>
+                  </p:cond>
+                </p:stCondLst>
+                <p:endSync evt="end" delay="0">
+                  <p:rtn val="all"/>
+                </p:endSync>
+                <p:childTnLst>
+                  <p:par>
+                    <p:cTn id="3" fill="hold">
+                      <p:stCondLst>
+                        <p:cond delay="0"/>
+                      </p:stCondLst>
+                      <p:childTnLst>
+                        <p:par>
+                          <p:cTn id="4" fill="hold">
+                            <p:stCondLst>
+                              <p:cond delay="0"/>
+                            </p:stCondLst>
+                            <p:childTnLst>
+                              <p:par>
+                                <p:cTn id="5" presetID="2" presetClass="mediacall" presetSubtype="0" fill="hold" nodeType="clickEffect">
+                                  <p:stCondLst>
+                                    <p:cond delay="0"/>
+                                  </p:stCondLst>
+                                  <p:childTnLst>
+                                    <p:cmd type="call" cmd="togglePause">
+                                      <p:cBhvr>
+                                        <p:cTn id="6" dur="1" fill="hold"/>
+                                        <p:tgtEl>
+                                          <p:spTgt spid="3"/>
+                                        </p:tgtEl>
+                                      </p:cBhvr>
+                                    </p:cmd>
+                                  </p:childTnLst>
+                                </p:cTn>
+                              </p:par>
+                            </p:childTnLst>
+                          </p:cTn>
+                        </p:par>
+                      </p:childTnLst>
+                    </p:cTn>
+                  </p:par>
+                </p:childTnLst>
+              </p:cTn>
+              <p:nextCondLst>
+                <p:cond evt="onClick" delay="0">
+                  <p:tgtEl>
+                    <p:spTgt spid="3"/>
+                  </p:tgtEl>
+                </p:cond>
+              </p:nextCondLst>
+            </p:seq>
+            <p:video>
+              <p:cMediaNode vol="80000">
+                <p:cTn id="7" fill="hold" display="0">
+                  <p:stCondLst>
+                    <p:cond delay="indefinite"/>
+                  </p:stCondLst>
+                </p:cTn>
+                <p:tgtEl>
+                  <p:spTgt spid="3"/>
+                </p:tgtEl>
+              </p:cMediaNode>
+            </p:video>
+          </p:childTnLst>
+        </p:cTn>
+      </p:par>
+    </p:tnLst>
+  </p:timing>
 </p:sld>
 </file>
 
@@ -6928,10 +6887,6 @@
               <a:rPr lang="ko-KR" altLang="en-US" dirty="0"/>
               <a:t>를 사용</a:t>
             </a:r>
-            <a:r>
-              <a:rPr lang="en-US" altLang="ko-KR" dirty="0"/>
-              <a:t/>
-            </a:r>
             <a:br>
               <a:rPr lang="en-US" altLang="ko-KR" dirty="0"/>
             </a:br>
@@ -6971,10 +6926,6 @@
             <a:r>
               <a:rPr lang="ko-KR" altLang="en-US" dirty="0"/>
               <a:t> 전달</a:t>
-            </a:r>
-            <a:r>
-              <a:rPr lang="en-US" altLang="ko-KR" dirty="0"/>
-              <a:t/>
             </a:r>
             <a:br>
               <a:rPr lang="en-US" altLang="ko-KR" dirty="0"/>
@@ -7383,12 +7334,8 @@
           </a:p>
           <a:p>
             <a:r>
-              <a:rPr lang="ko-KR" altLang="en-US" sz="2400" dirty="0" smtClean="0"/>
-              <a:t>모든 </a:t>
-            </a:r>
-            <a:r>
               <a:rPr lang="ko-KR" altLang="en-US" sz="2400" dirty="0"/>
-              <a:t>브라우저에서 이벤트를 동일하게 처리하기 위한 </a:t>
+              <a:t>모든 브라우저에서 이벤트를 동일하게 처리하기 위한 </a:t>
             </a:r>
             <a:r>
               <a:rPr lang="en-US" altLang="ko-KR" sz="2400" dirty="0"/>
@@ -8540,36 +8487,20 @@
           <a:p>
             <a:r>
               <a:rPr lang="ko-KR" altLang="en-US" dirty="0"/>
-              <a:t>함수에 인자가 </a:t>
-            </a:r>
-            <a:r>
-              <a:rPr lang="ko-KR" altLang="en-US" dirty="0" smtClean="0"/>
-              <a:t>없는 </a:t>
-            </a:r>
+              <a:t>함수에 인자가 없는 경우</a:t>
+            </a:r>
+            <a:endParaRPr lang="en-US" altLang="ko-KR" dirty="0"/>
+          </a:p>
+          <a:p>
+            <a:endParaRPr lang="en-US" altLang="ko-KR" dirty="0"/>
+          </a:p>
+          <a:p>
+            <a:endParaRPr lang="en-US" altLang="ko-KR" dirty="0"/>
+          </a:p>
+          <a:p>
             <a:r>
               <a:rPr lang="ko-KR" altLang="en-US" dirty="0"/>
-              <a:t>경우</a:t>
-            </a:r>
-            <a:endParaRPr lang="en-US" altLang="ko-KR" dirty="0"/>
-          </a:p>
-          <a:p>
-            <a:endParaRPr lang="en-US" altLang="ko-KR" dirty="0"/>
-          </a:p>
-          <a:p>
-            <a:endParaRPr lang="en-US" altLang="ko-KR" dirty="0"/>
-          </a:p>
-          <a:p>
-            <a:r>
-              <a:rPr lang="ko-KR" altLang="en-US" dirty="0"/>
-              <a:t>함수에 인자가 </a:t>
-            </a:r>
-            <a:r>
-              <a:rPr lang="ko-KR" altLang="en-US" dirty="0" smtClean="0"/>
-              <a:t>있는 </a:t>
-            </a:r>
-            <a:r>
-              <a:rPr lang="ko-KR" altLang="en-US" dirty="0"/>
-              <a:t>경우</a:t>
+              <a:t>함수에 인자가 있는 경우</a:t>
             </a:r>
           </a:p>
         </p:txBody>

</xml_diff>